<commit_message>
updated log log plot
</commit_message>
<xml_diff>
--- a/Week7/Week7_Slides.pptx
+++ b/Week7/Week7_Slides.pptx
@@ -19,6 +19,7 @@
     <p:sldId id="279" r:id="rId13"/>
     <p:sldId id="280" r:id="rId14"/>
     <p:sldId id="269" r:id="rId15"/>
+    <p:sldId id="281" r:id="rId16"/>
   </p:sldIdLst>
   <p:sldSz cx="12192000" cy="6858000"/>
   <p:notesSz cx="6858000" cy="9144000"/>
@@ -311,7 +312,7 @@
           <a:p>
             <a:fld id="{8322A558-B964-4799-A94A-632D1601F177}" type="datetimeFigureOut">
               <a:rPr lang="en-IN" smtClean="0"/>
-              <a:t>17-07-2025</a:t>
+              <a:t>29-07-2025</a:t>
             </a:fld>
             <a:endParaRPr lang="en-IN"/>
           </a:p>
@@ -586,7 +587,7 @@
           <a:p>
             <a:fld id="{8322A558-B964-4799-A94A-632D1601F177}" type="datetimeFigureOut">
               <a:rPr lang="en-IN" smtClean="0"/>
-              <a:t>17-07-2025</a:t>
+              <a:t>29-07-2025</a:t>
             </a:fld>
             <a:endParaRPr lang="en-IN"/>
           </a:p>
@@ -780,7 +781,7 @@
           <a:p>
             <a:fld id="{8322A558-B964-4799-A94A-632D1601F177}" type="datetimeFigureOut">
               <a:rPr lang="en-IN" smtClean="0"/>
-              <a:t>17-07-2025</a:t>
+              <a:t>29-07-2025</a:t>
             </a:fld>
             <a:endParaRPr lang="en-IN"/>
           </a:p>
@@ -1053,7 +1054,7 @@
           <a:p>
             <a:fld id="{8322A558-B964-4799-A94A-632D1601F177}" type="datetimeFigureOut">
               <a:rPr lang="en-IN" smtClean="0"/>
-              <a:t>17-07-2025</a:t>
+              <a:t>29-07-2025</a:t>
             </a:fld>
             <a:endParaRPr lang="en-IN"/>
           </a:p>
@@ -1394,7 +1395,7 @@
           <a:p>
             <a:fld id="{8322A558-B964-4799-A94A-632D1601F177}" type="datetimeFigureOut">
               <a:rPr lang="en-IN" smtClean="0"/>
-              <a:t>17-07-2025</a:t>
+              <a:t>29-07-2025</a:t>
             </a:fld>
             <a:endParaRPr lang="en-IN"/>
           </a:p>
@@ -2017,7 +2018,7 @@
           <a:p>
             <a:fld id="{8322A558-B964-4799-A94A-632D1601F177}" type="datetimeFigureOut">
               <a:rPr lang="en-IN" smtClean="0"/>
-              <a:t>17-07-2025</a:t>
+              <a:t>29-07-2025</a:t>
             </a:fld>
             <a:endParaRPr lang="en-IN"/>
           </a:p>
@@ -2877,7 +2878,7 @@
           <a:p>
             <a:fld id="{8322A558-B964-4799-A94A-632D1601F177}" type="datetimeFigureOut">
               <a:rPr lang="en-IN" smtClean="0"/>
-              <a:t>17-07-2025</a:t>
+              <a:t>29-07-2025</a:t>
             </a:fld>
             <a:endParaRPr lang="en-IN"/>
           </a:p>
@@ -3047,7 +3048,7 @@
           <a:p>
             <a:fld id="{8322A558-B964-4799-A94A-632D1601F177}" type="datetimeFigureOut">
               <a:rPr lang="en-IN" smtClean="0"/>
-              <a:t>17-07-2025</a:t>
+              <a:t>29-07-2025</a:t>
             </a:fld>
             <a:endParaRPr lang="en-IN"/>
           </a:p>
@@ -3227,7 +3228,7 @@
           <a:p>
             <a:fld id="{8322A558-B964-4799-A94A-632D1601F177}" type="datetimeFigureOut">
               <a:rPr lang="en-IN" smtClean="0"/>
-              <a:t>17-07-2025</a:t>
+              <a:t>29-07-2025</a:t>
             </a:fld>
             <a:endParaRPr lang="en-IN"/>
           </a:p>
@@ -3397,7 +3398,7 @@
           <a:p>
             <a:fld id="{8322A558-B964-4799-A94A-632D1601F177}" type="datetimeFigureOut">
               <a:rPr lang="en-IN" smtClean="0"/>
-              <a:t>17-07-2025</a:t>
+              <a:t>29-07-2025</a:t>
             </a:fld>
             <a:endParaRPr lang="en-IN"/>
           </a:p>
@@ -3644,7 +3645,7 @@
           <a:p>
             <a:fld id="{8322A558-B964-4799-A94A-632D1601F177}" type="datetimeFigureOut">
               <a:rPr lang="en-IN" smtClean="0"/>
-              <a:t>17-07-2025</a:t>
+              <a:t>29-07-2025</a:t>
             </a:fld>
             <a:endParaRPr lang="en-IN"/>
           </a:p>
@@ -3936,7 +3937,7 @@
           <a:p>
             <a:fld id="{8322A558-B964-4799-A94A-632D1601F177}" type="datetimeFigureOut">
               <a:rPr lang="en-IN" smtClean="0"/>
-              <a:t>17-07-2025</a:t>
+              <a:t>29-07-2025</a:t>
             </a:fld>
             <a:endParaRPr lang="en-IN"/>
           </a:p>
@@ -4380,7 +4381,7 @@
           <a:p>
             <a:fld id="{8322A558-B964-4799-A94A-632D1601F177}" type="datetimeFigureOut">
               <a:rPr lang="en-IN" smtClean="0"/>
-              <a:t>17-07-2025</a:t>
+              <a:t>29-07-2025</a:t>
             </a:fld>
             <a:endParaRPr lang="en-IN"/>
           </a:p>
@@ -4498,7 +4499,7 @@
           <a:p>
             <a:fld id="{8322A558-B964-4799-A94A-632D1601F177}" type="datetimeFigureOut">
               <a:rPr lang="en-IN" smtClean="0"/>
-              <a:t>17-07-2025</a:t>
+              <a:t>29-07-2025</a:t>
             </a:fld>
             <a:endParaRPr lang="en-IN"/>
           </a:p>
@@ -4593,7 +4594,7 @@
           <a:p>
             <a:fld id="{8322A558-B964-4799-A94A-632D1601F177}" type="datetimeFigureOut">
               <a:rPr lang="en-IN" smtClean="0"/>
-              <a:t>17-07-2025</a:t>
+              <a:t>29-07-2025</a:t>
             </a:fld>
             <a:endParaRPr lang="en-IN"/>
           </a:p>
@@ -4872,7 +4873,7 @@
           <a:p>
             <a:fld id="{8322A558-B964-4799-A94A-632D1601F177}" type="datetimeFigureOut">
               <a:rPr lang="en-IN" smtClean="0"/>
-              <a:t>17-07-2025</a:t>
+              <a:t>29-07-2025</a:t>
             </a:fld>
             <a:endParaRPr lang="en-IN"/>
           </a:p>
@@ -5147,7 +5148,7 @@
           <a:p>
             <a:fld id="{8322A558-B964-4799-A94A-632D1601F177}" type="datetimeFigureOut">
               <a:rPr lang="en-IN" smtClean="0"/>
-              <a:t>17-07-2025</a:t>
+              <a:t>29-07-2025</a:t>
             </a:fld>
             <a:endParaRPr lang="en-IN"/>
           </a:p>
@@ -5576,7 +5577,7 @@
           <a:p>
             <a:fld id="{8322A558-B964-4799-A94A-632D1601F177}" type="datetimeFigureOut">
               <a:rPr lang="en-IN" smtClean="0"/>
-              <a:t>17-07-2025</a:t>
+              <a:t>29-07-2025</a:t>
             </a:fld>
             <a:endParaRPr lang="en-IN"/>
           </a:p>
@@ -7121,6 +7122,101 @@
 </p:sld>
 </file>
 
+<file path=ppt/slides/slide15.xml><?xml version="1.0" encoding="utf-8"?>
+<p:sld xmlns:a="http://schemas.openxmlformats.org/drawingml/2006/main" xmlns:r="http://schemas.openxmlformats.org/officeDocument/2006/relationships" xmlns:p="http://schemas.openxmlformats.org/presentationml/2006/main">
+  <p:cSld>
+    <p:spTree>
+      <p:nvGrpSpPr>
+        <p:cNvPr id="1" name=""/>
+        <p:cNvGrpSpPr/>
+        <p:nvPr/>
+      </p:nvGrpSpPr>
+      <p:grpSpPr>
+        <a:xfrm>
+          <a:off x="0" y="0"/>
+          <a:ext cx="0" cy="0"/>
+          <a:chOff x="0" y="0"/>
+          <a:chExt cx="0" cy="0"/>
+        </a:xfrm>
+      </p:grpSpPr>
+      <p:sp>
+        <p:nvSpPr>
+          <p:cNvPr id="2" name="Title 1">
+            <a:extLst>
+              <a:ext uri="{FF2B5EF4-FFF2-40B4-BE49-F238E27FC236}">
+                <a16:creationId xmlns:a16="http://schemas.microsoft.com/office/drawing/2014/main" id="{D808C91D-EA50-E91F-BFAF-BBDEA51B89AE}"/>
+              </a:ext>
+            </a:extLst>
+          </p:cNvPr>
+          <p:cNvSpPr>
+            <a:spLocks noGrp="1"/>
+          </p:cNvSpPr>
+          <p:nvPr>
+            <p:ph type="title"/>
+          </p:nvPr>
+        </p:nvSpPr>
+        <p:spPr/>
+        <p:txBody>
+          <a:bodyPr/>
+          <a:lstStyle/>
+          <a:p>
+            <a:r>
+              <a:rPr lang="en-IN" b="1" dirty="0"/>
+              <a:t>Additional Information</a:t>
+            </a:r>
+            <a:br>
+              <a:rPr lang="en-IN" b="1" dirty="0"/>
+            </a:br>
+            <a:r>
+              <a:rPr lang="en-IN" b="1" dirty="0"/>
+              <a:t>(Log-Log Plot)</a:t>
+            </a:r>
+          </a:p>
+        </p:txBody>
+      </p:sp>
+      <p:pic>
+        <p:nvPicPr>
+          <p:cNvPr id="5" name="Picture 4">
+            <a:extLst>
+              <a:ext uri="{FF2B5EF4-FFF2-40B4-BE49-F238E27FC236}">
+                <a16:creationId xmlns:a16="http://schemas.microsoft.com/office/drawing/2014/main" id="{27BF2D64-9DB7-232E-1DB1-0B6E14079655}"/>
+              </a:ext>
+            </a:extLst>
+          </p:cNvPr>
+          <p:cNvPicPr>
+            <a:picLocks noChangeAspect="1"/>
+          </p:cNvPicPr>
+          <p:nvPr/>
+        </p:nvPicPr>
+        <p:blipFill>
+          <a:blip r:embed="rId2"/>
+          <a:stretch>
+            <a:fillRect/>
+          </a:stretch>
+        </p:blipFill>
+        <p:spPr>
+          <a:xfrm>
+            <a:off x="2899911" y="2016018"/>
+            <a:ext cx="6392178" cy="4524537"/>
+          </a:xfrm>
+          <a:prstGeom prst="rect">
+            <a:avLst/>
+          </a:prstGeom>
+        </p:spPr>
+      </p:pic>
+    </p:spTree>
+    <p:extLst>
+      <p:ext uri="{BB962C8B-B14F-4D97-AF65-F5344CB8AC3E}">
+        <p14:creationId xmlns:p14="http://schemas.microsoft.com/office/powerpoint/2010/main" val="4141559120"/>
+      </p:ext>
+    </p:extLst>
+  </p:cSld>
+  <p:clrMapOvr>
+    <a:masterClrMapping/>
+  </p:clrMapOvr>
+</p:sld>
+</file>
+
 <file path=ppt/slides/slide2.xml><?xml version="1.0" encoding="utf-8"?>
 <p:sld xmlns:a="http://schemas.openxmlformats.org/drawingml/2006/main" xmlns:r="http://schemas.openxmlformats.org/officeDocument/2006/relationships" xmlns:p="http://schemas.openxmlformats.org/presentationml/2006/main">
   <p:cSld>

</xml_diff>